<commit_message>
Reflect business-led initiation, AI Ops depth and monthly value review in FDE slides
Co-Authored-By: Claude Opus 5.5 <noreply@anthropic.com>
Claude-Session: https://claude.ai/code/session_01QouM6Vu5RyUNEDj5BHo7fD
</commit_message>
<xml_diff>
--- a/AX_2027_Cycle_Effect.pptx
+++ b/AX_2027_Cycle_Effect.pptx
@@ -1127,7 +1127,7 @@
                 <a:ea typeface="맑은 고딕" pitchFamily="34" charset="-122"/>
                 <a:cs typeface="맑은 고딕" pitchFamily="34" charset="-120"/>
               </a:rPr>
-              <a:t>① 현장 Embed</a:t>
+              <a:t>① 현업 공동발의</a:t>
             </a:r>
             <a:endParaRPr lang="en-US" sz="1000" dirty="0"/>
           </a:p>
@@ -1584,7 +1584,7 @@
                 <a:ea typeface="맑은 고딕" pitchFamily="34" charset="-122"/>
                 <a:cs typeface="맑은 고딕" pitchFamily="34" charset="-120"/>
               </a:rPr>
-              <a:t>안착</a:t>
+              <a:t>AI Ops</a:t>
             </a:r>
             <a:endParaRPr lang="en-US" sz="1000" dirty="0"/>
           </a:p>
@@ -1896,7 +1896,7 @@
               <a:buNone/>
             </a:pPr>
             <a:r>
-              <a:rPr lang="en-US" sz="950" dirty="0">
+              <a:rPr lang="en-US" sz="900" dirty="0">
                 <a:solidFill>
                   <a:srgbClr val="222222"/>
                 </a:solidFill>
@@ -1904,7 +1904,7 @@
                 <a:ea typeface="맑은 고딕" pitchFamily="34" charset="-122"/>
                 <a:cs typeface="맑은 고딕" pitchFamily="34" charset="-120"/>
               </a:rPr>
-              <a:t>KPI·ROI 실측</a:t>
+              <a:t>월간 포트폴리오 리뷰</a:t>
             </a:r>
             <a:endParaRPr lang="en-US" sz="950" dirty="0"/>
           </a:p>
@@ -1913,7 +1913,7 @@
               <a:buNone/>
             </a:pPr>
             <a:r>
-              <a:rPr lang="en-US" sz="950" dirty="0">
+              <a:rPr lang="en-US" sz="900" dirty="0">
                 <a:solidFill>
                   <a:srgbClr val="222222"/>
                 </a:solidFill>
@@ -1921,7 +1921,24 @@
                 <a:ea typeface="맑은 고딕" pitchFamily="34" charset="-122"/>
                 <a:cs typeface="맑은 고딕" pitchFamily="34" charset="-120"/>
               </a:rPr>
-              <a:t>→ 다음 사이클 반영</a:t>
+              <a:t>개선·중단 판단</a:t>
+            </a:r>
+            <a:endParaRPr lang="en-US" sz="950" dirty="0"/>
+          </a:p>
+          <a:p>
+            <a:pPr algn="ctr" indent="0" marL="0">
+              <a:buNone/>
+            </a:pPr>
+            <a:r>
+              <a:rPr lang="en-US" sz="900" dirty="0">
+                <a:solidFill>
+                  <a:srgbClr val="222222"/>
+                </a:solidFill>
+                <a:latin typeface="맑은 고딕" pitchFamily="34" charset="0"/>
+                <a:ea typeface="맑은 고딕" pitchFamily="34" charset="-122"/>
+                <a:cs typeface="맑은 고딕" pitchFamily="34" charset="-120"/>
+              </a:rPr>
+              <a:t>실측 ROI → G2 입력</a:t>
             </a:r>
             <a:endParaRPr lang="en-US" sz="950" dirty="0"/>
           </a:p>
@@ -2049,7 +2066,7 @@
                 <a:ea typeface="맑은 고딕" pitchFamily="34" charset="-122"/>
                 <a:cs typeface="맑은 고딕" pitchFamily="34" charset="-120"/>
               </a:rPr>
-              <a:t>현업 상주 문제 발굴</a:t>
+              <a:t>현업 공동 발의·투자(G1)</a:t>
             </a:r>
             <a:endParaRPr lang="en-US" sz="950" dirty="0"/>
           </a:p>
@@ -2339,7 +2356,7 @@
                 <a:ea typeface="맑은 고딕" pitchFamily="34" charset="-122"/>
                 <a:cs typeface="맑은 고딕" pitchFamily="34" charset="-120"/>
               </a:rPr>
-              <a:t>RACI·Hypercare 이관</a:t>
+              <a:t>AI Ops 체크리스트 이관</a:t>
             </a:r>
             <a:endParaRPr lang="en-US" sz="950" dirty="0"/>
           </a:p>
@@ -2364,14 +2381,63 @@
       </p:sp>
       <p:sp>
         <p:nvSpPr>
-          <p:cNvPr id="43" name="Text 41"/>
+          <p:cNvPr id="43" name="Shape 41"/>
+          <p:cNvSpPr/>
+          <p:nvPr/>
+        </p:nvSpPr>
+        <p:spPr>
+          <a:xfrm>
+            <a:off x="1874520" y="2395728"/>
+            <a:ext cx="658368" cy="274320"/>
+          </a:xfrm>
+          <a:prstGeom prst="line">
+            <a:avLst/>
+          </a:prstGeom>
+          <a:noFill/>
+          <a:ln w="12700">
+            <a:solidFill>
+              <a:srgbClr val="E0262B"/>
+            </a:solidFill>
+            <a:prstDash val="dash"/>
+            <a:tailEnd type="triangle"/>
+          </a:ln>
+        </p:spPr>
+      </p:sp>
+      <p:sp>
+        <p:nvSpPr>
+          <p:cNvPr id="44" name="Shape 42"/>
+          <p:cNvSpPr/>
+          <p:nvPr/>
+        </p:nvSpPr>
+        <p:spPr>
+          <a:xfrm>
+            <a:off x="457200" y="1938528"/>
+            <a:ext cx="1600200" cy="731520"/>
+          </a:xfrm>
+          <a:prstGeom prst="rect">
+            <a:avLst/>
+          </a:prstGeom>
+          <a:solidFill>
+            <a:srgbClr val="FDECEC"/>
+          </a:solidFill>
+          <a:ln w="12700">
+            <a:solidFill>
+              <a:srgbClr val="E0262B"/>
+            </a:solidFill>
+            <a:prstDash val="solid"/>
+          </a:ln>
+        </p:spPr>
+      </p:sp>
+      <p:sp>
+        <p:nvSpPr>
+          <p:cNvPr id="45" name="Text 43"/>
           <p:cNvSpPr txBox="1"/>
           <p:nvPr/>
         </p:nvSpPr>
         <p:spPr>
           <a:xfrm>
-            <a:off x="457200" y="1938528"/>
-            <a:ext cx="1463040" cy="228600"/>
+            <a:off x="530352" y="1938528"/>
+            <a:ext cx="1481328" cy="731520"/>
           </a:xfrm>
           <a:prstGeom prst="rect">
             <a:avLst/>
@@ -2387,79 +2453,57 @@
               <a:buNone/>
             </a:pPr>
             <a:r>
-              <a:rPr lang="en-US" sz="950" b="1" dirty="0">
-                <a:solidFill>
-                  <a:srgbClr val="6B6B6B"/>
-                </a:solidFill>
-                <a:latin typeface="맑은 고딕" pitchFamily="34" charset="0"/>
-                <a:ea typeface="맑은 고딕" pitchFamily="34" charset="-122"/>
-                <a:cs typeface="맑은 고딕" pitchFamily="34" charset="-120"/>
-              </a:rPr>
-              <a:t>성공요인</a:t>
-            </a:r>
-            <a:endParaRPr lang="en-US" sz="950" dirty="0"/>
-          </a:p>
-        </p:txBody>
-      </p:sp>
-      <p:sp>
-        <p:nvSpPr>
-          <p:cNvPr id="44" name="Text 42"/>
-          <p:cNvSpPr txBox="1"/>
-          <p:nvPr/>
-        </p:nvSpPr>
-        <p:spPr>
-          <a:xfrm>
-            <a:off x="457200" y="2157984"/>
-            <a:ext cx="1828800" cy="384048"/>
-          </a:xfrm>
-          <a:prstGeom prst="rect">
-            <a:avLst/>
-          </a:prstGeom>
-          <a:noFill/>
-          <a:ln/>
-        </p:spPr>
-        <p:txBody>
-          <a:bodyPr wrap="square" lIns="0" tIns="0" rIns="0" bIns="0" rtlCol="0" anchor="ctr"/>
-          <a:lstStyle/>
+              <a:rPr lang="en-US" sz="1050" b="1" dirty="0">
+                <a:solidFill>
+                  <a:srgbClr val="E0262B"/>
+                </a:solidFill>
+                <a:latin typeface="맑은 고딕" pitchFamily="34" charset="0"/>
+                <a:ea typeface="맑은 고딕" pitchFamily="34" charset="-122"/>
+                <a:cs typeface="맑은 고딕" pitchFamily="34" charset="-120"/>
+              </a:rPr>
+              <a:t>현업 발의 트랙</a:t>
+            </a:r>
+            <a:endParaRPr lang="en-US" sz="1050" dirty="0"/>
+          </a:p>
           <a:p>
             <a:pPr indent="0" marL="0">
               <a:buNone/>
             </a:pPr>
             <a:r>
-              <a:rPr lang="en-US" sz="900" dirty="0">
-                <a:solidFill>
-                  <a:srgbClr val="6B6B6B"/>
-                </a:solidFill>
-                <a:latin typeface="맑은 고딕" pitchFamily="34" charset="0"/>
-                <a:ea typeface="맑은 고딕" pitchFamily="34" charset="-122"/>
-                <a:cs typeface="맑은 고딕" pitchFamily="34" charset="-120"/>
-              </a:rPr>
-              <a:t>1~3 : 외곽 그룹</a:t>
-            </a:r>
-            <a:endParaRPr lang="en-US" sz="900" dirty="0"/>
+              <a:rPr lang="en-US" sz="950" dirty="0">
+                <a:solidFill>
+                  <a:srgbClr val="222222"/>
+                </a:solidFill>
+                <a:latin typeface="맑은 고딕" pitchFamily="34" charset="0"/>
+                <a:ea typeface="맑은 고딕" pitchFamily="34" charset="-122"/>
+                <a:cs typeface="맑은 고딕" pitchFamily="34" charset="-120"/>
+              </a:rPr>
+              <a:t>Hypercare 이후 현업이</a:t>
+            </a:r>
+            <a:endParaRPr lang="en-US" sz="1050" dirty="0"/>
           </a:p>
           <a:p>
             <a:pPr indent="0" marL="0">
               <a:buNone/>
             </a:pPr>
             <a:r>
-              <a:rPr lang="en-US" sz="900" dirty="0">
-                <a:solidFill>
-                  <a:srgbClr val="6B6B6B"/>
-                </a:solidFill>
-                <a:latin typeface="맑은 고딕" pitchFamily="34" charset="0"/>
-                <a:ea typeface="맑은 고딕" pitchFamily="34" charset="-122"/>
-                <a:cs typeface="맑은 고딕" pitchFamily="34" charset="-120"/>
-              </a:rPr>
-              <a:t>4 : 중심 Hub (전 단계 공통)</a:t>
-            </a:r>
-            <a:endParaRPr lang="en-US" sz="900" dirty="0"/>
-          </a:p>
-        </p:txBody>
-      </p:sp>
-      <p:sp>
-        <p:nvSpPr>
-          <p:cNvPr id="45" name="Shape 43"/>
+              <a:rPr lang="en-US" sz="950" dirty="0">
+                <a:solidFill>
+                  <a:srgbClr val="222222"/>
+                </a:solidFill>
+                <a:latin typeface="맑은 고딕" pitchFamily="34" charset="0"/>
+                <a:ea typeface="맑은 고딕" pitchFamily="34" charset="-122"/>
+                <a:cs typeface="맑은 고딕" pitchFamily="34" charset="-120"/>
+              </a:rPr>
+              <a:t>자체 과제 발의 → ①</a:t>
+            </a:r>
+            <a:endParaRPr lang="en-US" sz="1050" dirty="0"/>
+          </a:p>
+        </p:txBody>
+      </p:sp>
+      <p:sp>
+        <p:nvSpPr>
+          <p:cNvPr id="46" name="Shape 44"/>
           <p:cNvSpPr/>
           <p:nvPr/>
         </p:nvSpPr>
@@ -2484,7 +2528,7 @@
       </p:sp>
       <p:sp>
         <p:nvSpPr>
-          <p:cNvPr id="46" name="Text 44"/>
+          <p:cNvPr id="47" name="Text 45"/>
           <p:cNvSpPr txBox="1"/>
           <p:nvPr/>
         </p:nvSpPr>
@@ -2529,7 +2573,7 @@
                 <a:ea typeface="맑은 고딕" pitchFamily="34" charset="-122"/>
                 <a:cs typeface="맑은 고딕" pitchFamily="34" charset="-120"/>
               </a:rPr>
-              <a:t>FDE 공동 스쿼드 = FD (문제정의·KPI·운영모델) + PRD (Data·Agent 구축·운영 이관)</a:t>
+              <a:t>FDE 스쿼드 = 현업(Owner·공동 투자) + FD(문제정의·KPI) + PRD(구축·AI Ops)</a:t>
             </a:r>
             <a:endParaRPr lang="en-US" sz="950" dirty="0"/>
           </a:p>
@@ -2537,7 +2581,7 @@
       </p:sp>
       <p:sp>
         <p:nvSpPr>
-          <p:cNvPr id="47" name="Shape 45"/>
+          <p:cNvPr id="48" name="Shape 46"/>
           <p:cNvSpPr/>
           <p:nvPr/>
         </p:nvSpPr>
@@ -2583,7 +2627,7 @@
       </p:sp>
       <p:sp>
         <p:nvSpPr>
-          <p:cNvPr id="48" name="Text 46"/>
+          <p:cNvPr id="49" name="Text 47"/>
           <p:cNvSpPr txBox="1"/>
           <p:nvPr/>
         </p:nvSpPr>
@@ -2622,7 +2666,7 @@
       </p:sp>
       <p:sp>
         <p:nvSpPr>
-          <p:cNvPr id="49" name="Shape 47"/>
+          <p:cNvPr id="50" name="Shape 48"/>
           <p:cNvSpPr/>
           <p:nvPr/>
         </p:nvSpPr>
@@ -2645,7 +2689,7 @@
       </p:sp>
       <p:sp>
         <p:nvSpPr>
-          <p:cNvPr id="50" name="Shape 48"/>
+          <p:cNvPr id="51" name="Shape 49"/>
           <p:cNvSpPr/>
           <p:nvPr/>
         </p:nvSpPr>
@@ -2670,7 +2714,7 @@
       </p:sp>
       <p:sp>
         <p:nvSpPr>
-          <p:cNvPr id="51" name="Shape 49"/>
+          <p:cNvPr id="52" name="Shape 50"/>
           <p:cNvSpPr/>
           <p:nvPr/>
         </p:nvSpPr>
@@ -2695,7 +2739,7 @@
       </p:sp>
       <p:sp>
         <p:nvSpPr>
-          <p:cNvPr id="52" name="Text 50"/>
+          <p:cNvPr id="53" name="Text 51"/>
           <p:cNvSpPr txBox="1"/>
           <p:nvPr/>
         </p:nvSpPr>
@@ -2751,7 +2795,7 @@
       </p:sp>
       <p:sp>
         <p:nvSpPr>
-          <p:cNvPr id="53" name="Shape 51"/>
+          <p:cNvPr id="54" name="Shape 52"/>
           <p:cNvSpPr/>
           <p:nvPr/>
         </p:nvSpPr>
@@ -2776,7 +2820,7 @@
       </p:sp>
       <p:sp>
         <p:nvSpPr>
-          <p:cNvPr id="54" name="Text 52"/>
+          <p:cNvPr id="55" name="Text 53"/>
           <p:cNvSpPr txBox="1"/>
           <p:nvPr/>
         </p:nvSpPr>
@@ -2832,7 +2876,7 @@
       </p:sp>
       <p:sp>
         <p:nvSpPr>
-          <p:cNvPr id="55" name="Text 53"/>
+          <p:cNvPr id="56" name="Text 54"/>
           <p:cNvSpPr txBox="1"/>
           <p:nvPr/>
         </p:nvSpPr>
@@ -2871,7 +2915,7 @@
       </p:sp>
       <p:sp>
         <p:nvSpPr>
-          <p:cNvPr id="56" name="Text 54"/>
+          <p:cNvPr id="57" name="Text 55"/>
           <p:cNvSpPr txBox="1"/>
           <p:nvPr/>
         </p:nvSpPr>
@@ -2911,7 +2955,7 @@
                 <a:ea typeface="맑은 고딕" pitchFamily="34" charset="-122"/>
                 <a:cs typeface="맑은 고딕" pitchFamily="34" charset="-120"/>
               </a:rPr>
-              <a:t>과제 발굴 → 본사업·운영 전환율 향상</a:t>
+              <a:t>현업 공동 발의·투자로 본사업·운영 전환율 향상</a:t>
             </a:r>
             <a:endParaRPr lang="en-US" sz="1000" dirty="0"/>
           </a:p>
@@ -2932,7 +2976,7 @@
                 <a:ea typeface="맑은 고딕" pitchFamily="34" charset="-122"/>
                 <a:cs typeface="맑은 고딕" pitchFamily="34" charset="-120"/>
               </a:rPr>
-              <a:t>현장 기반 문제정의로 실효성 높은 과제 선정</a:t>
+              <a:t>Hypercare 이후 현업 자체 발의 과제 확대</a:t>
             </a:r>
             <a:endParaRPr lang="en-US" sz="1000" dirty="0"/>
           </a:p>
@@ -2940,7 +2984,7 @@
       </p:sp>
       <p:sp>
         <p:nvSpPr>
-          <p:cNvPr id="57" name="Shape 55"/>
+          <p:cNvPr id="58" name="Shape 56"/>
           <p:cNvSpPr/>
           <p:nvPr/>
         </p:nvSpPr>
@@ -2963,7 +3007,7 @@
       </p:sp>
       <p:sp>
         <p:nvSpPr>
-          <p:cNvPr id="58" name="Shape 56"/>
+          <p:cNvPr id="59" name="Shape 57"/>
           <p:cNvSpPr/>
           <p:nvPr/>
         </p:nvSpPr>
@@ -2988,7 +3032,7 @@
       </p:sp>
       <p:sp>
         <p:nvSpPr>
-          <p:cNvPr id="59" name="Text 57"/>
+          <p:cNvPr id="60" name="Text 58"/>
           <p:cNvSpPr txBox="1"/>
           <p:nvPr/>
         </p:nvSpPr>
@@ -3044,7 +3088,7 @@
       </p:sp>
       <p:sp>
         <p:nvSpPr>
-          <p:cNvPr id="60" name="Text 58"/>
+          <p:cNvPr id="61" name="Text 59"/>
           <p:cNvSpPr txBox="1"/>
           <p:nvPr/>
         </p:nvSpPr>
@@ -3083,7 +3127,7 @@
       </p:sp>
       <p:sp>
         <p:nvSpPr>
-          <p:cNvPr id="61" name="Text 59"/>
+          <p:cNvPr id="62" name="Text 60"/>
           <p:cNvSpPr txBox="1"/>
           <p:nvPr/>
         </p:nvSpPr>
@@ -3118,7 +3162,7 @@
                 <a:ea typeface="맑은 고딕" pitchFamily="34" charset="-122"/>
                 <a:cs typeface="맑은 고딕" pitchFamily="34" charset="-120"/>
               </a:rPr>
-              <a:t>KPI·ROI 상시 측정으로 투자 의사결정 근거 확보</a:t>
+              <a:t>월간 포트폴리오 리뷰로 저성과 과제 개선·중단</a:t>
             </a:r>
             <a:endParaRPr lang="en-US" sz="1000" dirty="0"/>
           </a:p>
@@ -3139,7 +3183,7 @@
                 <a:ea typeface="맑은 고딕" pitchFamily="34" charset="-122"/>
                 <a:cs typeface="맑은 고딕" pitchFamily="34" charset="-120"/>
               </a:rPr>
-              <a:t>성과 기반 과제 포트폴리오 관리</a:t>
+              <a:t>실측 ROI 기반 투자 Gate(G2) 의사결정</a:t>
             </a:r>
             <a:endParaRPr lang="en-US" sz="1000" dirty="0"/>
           </a:p>
@@ -3147,7 +3191,7 @@
       </p:sp>
       <p:sp>
         <p:nvSpPr>
-          <p:cNvPr id="62" name="Shape 60"/>
+          <p:cNvPr id="63" name="Shape 61"/>
           <p:cNvSpPr/>
           <p:nvPr/>
         </p:nvSpPr>
@@ -3170,7 +3214,7 @@
       </p:sp>
       <p:sp>
         <p:nvSpPr>
-          <p:cNvPr id="63" name="Shape 61"/>
+          <p:cNvPr id="64" name="Shape 62"/>
           <p:cNvSpPr/>
           <p:nvPr/>
         </p:nvSpPr>
@@ -3195,7 +3239,7 @@
       </p:sp>
       <p:sp>
         <p:nvSpPr>
-          <p:cNvPr id="64" name="Text 62"/>
+          <p:cNvPr id="65" name="Text 63"/>
           <p:cNvSpPr txBox="1"/>
           <p:nvPr/>
         </p:nvSpPr>
@@ -3251,7 +3295,7 @@
       </p:sp>
       <p:sp>
         <p:nvSpPr>
-          <p:cNvPr id="65" name="Text 63"/>
+          <p:cNvPr id="66" name="Text 64"/>
           <p:cNvSpPr txBox="1"/>
           <p:nvPr/>
         </p:nvSpPr>
@@ -3290,7 +3334,7 @@
       </p:sp>
       <p:sp>
         <p:nvSpPr>
-          <p:cNvPr id="66" name="Text 64"/>
+          <p:cNvPr id="67" name="Text 65"/>
           <p:cNvSpPr txBox="1"/>
           <p:nvPr/>
         </p:nvSpPr>
@@ -3354,7 +3398,7 @@
       </p:sp>
       <p:sp>
         <p:nvSpPr>
-          <p:cNvPr id="67" name="Shape 65"/>
+          <p:cNvPr id="68" name="Shape 66"/>
           <p:cNvSpPr/>
           <p:nvPr/>
         </p:nvSpPr>
@@ -3379,7 +3423,7 @@
       </p:sp>
       <p:sp>
         <p:nvSpPr>
-          <p:cNvPr id="68" name="Text 66"/>
+          <p:cNvPr id="69" name="Text 67"/>
           <p:cNvSpPr txBox="1"/>
           <p:nvPr/>
         </p:nvSpPr>
@@ -3418,7 +3462,7 @@
       </p:sp>
       <p:sp>
         <p:nvSpPr>
-          <p:cNvPr id="69" name="Shape 67"/>
+          <p:cNvPr id="70" name="Shape 68"/>
           <p:cNvSpPr/>
           <p:nvPr/>
         </p:nvSpPr>
@@ -3443,7 +3487,7 @@
       </p:sp>
       <p:sp>
         <p:nvSpPr>
-          <p:cNvPr id="70" name="Text 68"/>
+          <p:cNvPr id="71" name="Text 69"/>
           <p:cNvSpPr txBox="1"/>
           <p:nvPr/>
         </p:nvSpPr>
@@ -3499,7 +3543,7 @@
       </p:sp>
       <p:sp>
         <p:nvSpPr>
-          <p:cNvPr id="71" name="Text 69"/>
+          <p:cNvPr id="72" name="Text 70"/>
           <p:cNvSpPr txBox="1"/>
           <p:nvPr/>
         </p:nvSpPr>
@@ -3538,7 +3582,7 @@
       </p:sp>
       <p:sp>
         <p:nvSpPr>
-          <p:cNvPr id="72" name="Text 70"/>
+          <p:cNvPr id="73" name="Text 71"/>
           <p:cNvSpPr txBox="1"/>
           <p:nvPr/>
         </p:nvSpPr>
@@ -3607,7 +3651,7 @@
       </p:sp>
       <p:sp>
         <p:nvSpPr>
-          <p:cNvPr id="73" name="Shape 71"/>
+          <p:cNvPr id="74" name="Shape 72"/>
           <p:cNvSpPr/>
           <p:nvPr/>
         </p:nvSpPr>
@@ -3630,7 +3674,7 @@
       </p:sp>
       <p:sp>
         <p:nvSpPr>
-          <p:cNvPr id="74" name="Shape 72"/>
+          <p:cNvPr id="75" name="Shape 73"/>
           <p:cNvSpPr/>
           <p:nvPr/>
         </p:nvSpPr>
@@ -3655,7 +3699,7 @@
       </p:sp>
       <p:sp>
         <p:nvSpPr>
-          <p:cNvPr id="75" name="Text 73"/>
+          <p:cNvPr id="76" name="Text 74"/>
           <p:cNvSpPr txBox="1"/>
           <p:nvPr/>
         </p:nvSpPr>
@@ -3686,7 +3730,7 @@
                 <a:ea typeface="맑은 고딕" pitchFamily="34" charset="-122"/>
                 <a:cs typeface="맑은 고딕" pitchFamily="34" charset="-120"/>
               </a:rPr>
-              <a:t>Biz+Engineering</a:t>
+              <a:t>Biz+Eng+Ops</a:t>
             </a:r>
             <a:endParaRPr lang="en-US" sz="1050" dirty="0"/>
           </a:p>
@@ -3711,7 +3755,7 @@
       </p:sp>
       <p:sp>
         <p:nvSpPr>
-          <p:cNvPr id="76" name="Text 74"/>
+          <p:cNvPr id="77" name="Text 75"/>
           <p:cNvSpPr txBox="1"/>
           <p:nvPr/>
         </p:nvSpPr>
@@ -3742,7 +3786,7 @@
                 <a:ea typeface="맑은 고딕" pitchFamily="34" charset="-122"/>
                 <a:cs typeface="맑은 고딕" pitchFamily="34" charset="-120"/>
               </a:rPr>
-              <a:t>성공요인 1·2</a:t>
+              <a:t>성공요인 1·2·3</a:t>
             </a:r>
             <a:endParaRPr lang="en-US" sz="800" dirty="0"/>
           </a:p>
@@ -3750,7 +3794,7 @@
       </p:sp>
       <p:sp>
         <p:nvSpPr>
-          <p:cNvPr id="77" name="Text 75"/>
+          <p:cNvPr id="78" name="Text 76"/>
           <p:cNvSpPr txBox="1"/>
           <p:nvPr/>
         </p:nvSpPr>
@@ -3806,7 +3850,7 @@
                 <a:ea typeface="맑은 고딕" pitchFamily="34" charset="-122"/>
                 <a:cs typeface="맑은 고딕" pitchFamily="34" charset="-120"/>
               </a:rPr>
-              <a:t>Data Readiness·MCP 구축 역량 축적</a:t>
+              <a:t>AI Ops 표준(드리프트·비용 관리) 운영 역량</a:t>
             </a:r>
             <a:endParaRPr lang="en-US" sz="1000" dirty="0"/>
           </a:p>
@@ -3814,7 +3858,7 @@
       </p:sp>
       <p:sp>
         <p:nvSpPr>
-          <p:cNvPr id="78" name="Shape 76"/>
+          <p:cNvPr id="79" name="Shape 77"/>
           <p:cNvSpPr/>
           <p:nvPr/>
         </p:nvSpPr>
@@ -3837,7 +3881,7 @@
       </p:sp>
       <p:sp>
         <p:nvSpPr>
-          <p:cNvPr id="79" name="Shape 77"/>
+          <p:cNvPr id="80" name="Shape 78"/>
           <p:cNvSpPr/>
           <p:nvPr/>
         </p:nvSpPr>
@@ -3862,7 +3906,7 @@
       </p:sp>
       <p:sp>
         <p:nvSpPr>
-          <p:cNvPr id="80" name="Text 78"/>
+          <p:cNvPr id="81" name="Text 79"/>
           <p:cNvSpPr txBox="1"/>
           <p:nvPr/>
         </p:nvSpPr>
@@ -3918,7 +3962,7 @@
       </p:sp>
       <p:sp>
         <p:nvSpPr>
-          <p:cNvPr id="81" name="Text 79"/>
+          <p:cNvPr id="82" name="Text 80"/>
           <p:cNvSpPr txBox="1"/>
           <p:nvPr/>
         </p:nvSpPr>
@@ -3957,7 +4001,7 @@
       </p:sp>
       <p:sp>
         <p:nvSpPr>
-          <p:cNvPr id="82" name="Text 80"/>
+          <p:cNvPr id="83" name="Text 81"/>
           <p:cNvSpPr txBox="1"/>
           <p:nvPr/>
         </p:nvSpPr>

</xml_diff>